<commit_message>
feat: enhance design guidelines and validation for slide presentations
Updated design-system.md and layout-canonical.md to clarify hard and soft limits for slide content areas, ensuring compliance with the canonical layout. Introduced a new script, check_useful_area.py, to validate slide dimensions before packaging. Adjusted build_aula2_bloco1.py to incorporate these changes, ensuring proper media swapping and layout consistency. Enhanced documentation on stylish design patterns and validation processes for improved clarity and usability.
</commit_message>
<xml_diff>
--- a/aulas/aula_02/slides/aula2_bloco1_jurimetria.pptx
+++ b/aulas/aula_02/slides/aula2_bloco1_jurimetria.pptx
@@ -2867,7 +2867,7 @@
               <a:buNone/>
             </a:pPr>
             <a:r>
-              <a:rPr lang="pt-BR" sz="3600" b="1" i="0">
+              <a:rPr lang="pt-BR" sz="3200" b="1" i="0">
                 <a:solidFill>
                   <a:srgbClr val="1B2A4A"/>
                 </a:solidFill>
@@ -3113,7 +3113,7 @@
                 <a:ea typeface="Arial Black"/>
                 <a:cs typeface="Arial Black"/>
               </a:rPr>
-              <a:t>Da pergunta solta à pergunta de dados</a:t>
+              <a:t>Da intuição à pergunta de dados</a:t>
             </a:r>
           </a:p>
         </p:txBody>
@@ -3366,7 +3366,7 @@
         <p:spPr>
           <a:xfrm>
             <a:off x="1097275" y="900000"/>
-            <a:ext cx="1800000" cy="1100000"/>
+            <a:ext cx="2400000" cy="1100000"/>
           </a:xfrm>
           <a:prstGeom prst="rect">
             <a:avLst/>
@@ -5936,7 +5936,7 @@
                 <a:ea typeface="Arial Black"/>
                 <a:cs typeface="Arial Black"/>
               </a:rPr>
-              <a:t>Cadeia de custódia: do processo ao dado</a:t>
+              <a:t>Cadeia de custódia analítica</a:t>
             </a:r>
           </a:p>
         </p:txBody>
@@ -6189,7 +6189,7 @@
         <p:spPr>
           <a:xfrm>
             <a:off x="1097275" y="900000"/>
-            <a:ext cx="1800000" cy="1100000"/>
+            <a:ext cx="2400000" cy="1100000"/>
           </a:xfrm>
           <a:prstGeom prst="rect">
             <a:avLst/>
@@ -6261,7 +6261,7 @@
                 <a:ea typeface="Arial Black"/>
                 <a:cs typeface="Arial Black"/>
               </a:rPr>
-              <a:t>Etapa 1: transformar a pergunta</a:t>
+              <a:t>Etapa 1: a pergunta</a:t>
             </a:r>
           </a:p>
         </p:txBody>
@@ -7897,7 +7897,7 @@
               <a:buChar char="•"/>
             </a:pPr>
             <a:r>
-              <a:rPr lang="pt-BR" sz="1100" b="0" i="0">
+              <a:rPr lang="pt-BR" sz="1250" b="0" i="0">
                 <a:solidFill>
                   <a:srgbClr val="333333"/>
                 </a:solidFill>
@@ -7923,7 +7923,7 @@
               <a:buChar char="•"/>
             </a:pPr>
             <a:r>
-              <a:rPr lang="pt-BR" sz="1100" b="0" i="0">
+              <a:rPr lang="pt-BR" sz="1250" b="0" i="0">
                 <a:solidFill>
                   <a:srgbClr val="333333"/>
                 </a:solidFill>
@@ -7949,7 +7949,7 @@
               <a:buChar char="•"/>
             </a:pPr>
             <a:r>
-              <a:rPr lang="pt-BR" sz="1100" b="0" i="0">
+              <a:rPr lang="pt-BR" sz="1250" b="0" i="0">
                 <a:solidFill>
                   <a:srgbClr val="333333"/>
                 </a:solidFill>
@@ -7975,7 +7975,7 @@
               <a:buChar char="•"/>
             </a:pPr>
             <a:r>
-              <a:rPr lang="pt-BR" sz="1100" b="0" i="0">
+              <a:rPr lang="pt-BR" sz="1250" b="0" i="0">
                 <a:solidFill>
                   <a:srgbClr val="333333"/>
                 </a:solidFill>
@@ -8022,7 +8022,7 @@
               <a:buChar char="•"/>
             </a:pPr>
             <a:r>
-              <a:rPr lang="pt-BR" sz="1100" b="0" i="0">
+              <a:rPr lang="pt-BR" sz="1250" b="0" i="0">
                 <a:solidFill>
                   <a:srgbClr val="333333"/>
                 </a:solidFill>
@@ -8030,7 +8030,7 @@
                 <a:ea typeface="Arial"/>
                 <a:cs typeface="Arial"/>
               </a:rPr>
-              <a:t>Revisões no TJSP, 2018 a 2024: a taxa de procedência do juízo X difere da média?</a:t>
+              <a:t>Revisões TJSP 2018-2024: procedência do juízo X vs. média?</a:t>
             </a:r>
           </a:p>
           <a:p>
@@ -8048,7 +8048,7 @@
               <a:buChar char="•"/>
             </a:pPr>
             <a:r>
-              <a:rPr lang="pt-BR" sz="1100" b="0" i="0">
+              <a:rPr lang="pt-BR" sz="1250" b="0" i="0">
                 <a:solidFill>
                   <a:srgbClr val="333333"/>
                 </a:solidFill>
@@ -8056,7 +8056,7 @@
                 <a:ea typeface="Arial"/>
                 <a:cs typeface="Arial"/>
               </a:rPr>
-              <a:t>Renovatórias: o tempo mediano até sentença subiu entre 2019 e 2024 na Capital?</a:t>
+              <a:t>Renovatórias: tempo mediano até sentença subiu de 2019 a 2024?</a:t>
             </a:r>
           </a:p>
           <a:p>
@@ -8074,7 +8074,7 @@
               <a:buChar char="•"/>
             </a:pPr>
             <a:r>
-              <a:rPr lang="pt-BR" sz="1100" b="0" i="0">
+              <a:rPr lang="pt-BR" sz="1250" b="0" i="0">
                 <a:solidFill>
                   <a:srgbClr val="333333"/>
                 </a:solidFill>
@@ -8082,7 +8082,7 @@
                 <a:ea typeface="Arial"/>
                 <a:cs typeface="Arial"/>
               </a:rPr>
-              <a:t>Recursos de revisão, 2020 a 2024: qual a proporção de reformas a favor do recorrente?</a:t>
+              <a:t>Revisão 2020-2024: proporção de reformas a favor do recorrente?</a:t>
             </a:r>
           </a:p>
           <a:p>
@@ -8100,7 +8100,7 @@
               <a:buChar char="•"/>
             </a:pPr>
             <a:r>
-              <a:rPr lang="pt-BR" sz="1100" b="0" i="0">
+              <a:rPr lang="pt-BR" sz="1250" b="0" i="0">
                 <a:solidFill>
                   <a:srgbClr val="333333"/>
                 </a:solidFill>
@@ -8108,7 +8108,7 @@
                 <a:ea typeface="Arial"/>
                 <a:cs typeface="Arial"/>
               </a:rPr>
-              <a:t>Acordos, 2022 a 2024: o valor acordado é qual fração do valor da causa?</a:t>
+              <a:t>Acordos 2022-2024: valor acordado vs. valor da causa?</a:t>
             </a:r>
           </a:p>
         </p:txBody>
@@ -8469,7 +8469,7 @@
                 <a:ea typeface="Arial Black"/>
                 <a:cs typeface="Arial Black"/>
               </a:rPr>
-              <a:t>Armadilhas comuns ao formular perguntas</a:t>
+              <a:t>Armadilhas ao formular</a:t>
             </a:r>
           </a:p>
         </p:txBody>
@@ -8511,8 +8511,8 @@
         </p:nvSpPr>
         <p:spPr>
           <a:xfrm>
-            <a:off x="750000" y="1800000"/>
-            <a:ext cx="5950000" cy="700000"/>
+            <a:off x="750000" y="1750000"/>
+            <a:ext cx="5950000" cy="820000"/>
           </a:xfrm>
           <a:prstGeom prst="roundRect">
             <a:avLst>
@@ -8579,8 +8579,8 @@
         </p:nvSpPr>
         <p:spPr>
           <a:xfrm>
-            <a:off x="750000" y="2550000"/>
-            <a:ext cx="5950000" cy="700000"/>
+            <a:off x="750000" y="2600000"/>
+            <a:ext cx="5950000" cy="820000"/>
           </a:xfrm>
           <a:prstGeom prst="roundRect">
             <a:avLst>
@@ -8647,8 +8647,8 @@
         </p:nvSpPr>
         <p:spPr>
           <a:xfrm>
-            <a:off x="750000" y="3300000"/>
-            <a:ext cx="5950000" cy="700000"/>
+            <a:off x="750000" y="3450000"/>
+            <a:ext cx="5950000" cy="820000"/>
           </a:xfrm>
           <a:prstGeom prst="roundRect">
             <a:avLst>
@@ -9336,7 +9336,7 @@
         <p:spPr>
           <a:xfrm>
             <a:off x="1097275" y="900000"/>
-            <a:ext cx="1800000" cy="1100000"/>
+            <a:ext cx="2400000" cy="1100000"/>
           </a:xfrm>
           <a:prstGeom prst="rect">
             <a:avLst/>
@@ -9408,7 +9408,7 @@
                 <a:ea typeface="Arial Black"/>
                 <a:cs typeface="Arial Black"/>
               </a:rPr>
-              <a:t>Etapa 2: mapear as informações</a:t>
+              <a:t>Etapa 2: mapeamento</a:t>
             </a:r>
           </a:p>
         </p:txBody>
@@ -15557,7 +15557,7 @@
         <p:spPr>
           <a:xfrm>
             <a:off x="1097275" y="900000"/>
-            <a:ext cx="1800000" cy="1100000"/>
+            <a:ext cx="2400000" cy="1100000"/>
           </a:xfrm>
           <a:prstGeom prst="rect">
             <a:avLst/>
@@ -15629,7 +15629,7 @@
                 <a:ea typeface="Arial Black"/>
                 <a:cs typeface="Arial Black"/>
               </a:rPr>
-              <a:t>Atividade 1: o que aprendemos</a:t>
+              <a:t>Atividade 1: revisão</a:t>
             </a:r>
           </a:p>
         </p:txBody>

</xml_diff>